<commit_message>
feat(sits9): add 3 Pachelbel schema figures (score, textile, cooking)
- Figure 2: Harmonic tension profile (bar chart with SITS9 instructions)
- Figure 3: Textile schema (back-stitch needle path, surface/back)
- Figure 4: Cooking schema (heat curve + method zones)
- All 3 inline in Leonardo docx + added to PPTX
- Updated EXCLUDE_MAP to exclude create_pachelbel_schemas.py from public sync

Co-Authored-By: Tatsuki Onishi <bougtoir@gmail.com>
</commit_message>
<xml_diff>
--- a/sits9/output/sits9_figures.pptx
+++ b/sits9/output/sits9_figures.pptx
@@ -6,6 +6,9 @@
   </p:sldMasterIdLst>
   <p:sldIdLst>
     <p:sldId id="256" r:id="rId7"/>
+    <p:sldId id="257" r:id="rId8"/>
+    <p:sldId id="258" r:id="rId9"/>
+    <p:sldId id="259" r:id="rId10"/>
   </p:sldIdLst>
   <p:sldSz cx="12191695" cy="6858000" type="screen4x3"/>
   <p:notesSz cx="6858000" cy="9144000"/>
@@ -3183,6 +3186,357 @@
             <a:r>
               <a:rPr sz="1400" i="1"/>
               <a:t>Figure 1. SITS9 Loom Renderer output for Pachelbel's Canon (I-V-vi-iii-IV-I-IV-V, 2 loops). Red solid lines = surface stitches; grey dashed lines = back stitches; filled black circles = anchor points (knots).</a:t>
+            </a:r>
+          </a:p>
+        </p:txBody>
+      </p:sp>
+    </p:spTree>
+  </p:cSld>
+  <p:clrMapOvr>
+    <a:masterClrMapping/>
+  </p:clrMapOvr>
+</p:sld>
+</file>
+
+<file path=ppt/slides/slide2.xml><?xml version="1.0" encoding="utf-8"?>
+<p:sld xmlns:a="http://schemas.openxmlformats.org/drawingml/2006/main" xmlns:p="http://schemas.openxmlformats.org/presentationml/2006/main" xmlns:r="http://schemas.openxmlformats.org/officeDocument/2006/relationships">
+  <p:cSld>
+    <p:spTree>
+      <p:nvGrpSpPr>
+        <p:cNvPr id="1" name=""/>
+        <p:cNvGrpSpPr/>
+        <p:nvPr/>
+      </p:nvGrpSpPr>
+      <p:grpSpPr/>
+      <p:sp>
+        <p:nvSpPr>
+          <p:cNvPr id="2" name="Title 1"/>
+          <p:cNvSpPr>
+            <a:spLocks noGrp="1"/>
+          </p:cNvSpPr>
+          <p:nvPr>
+            <p:ph type="title"/>
+          </p:nvPr>
+        </p:nvSpPr>
+        <p:spPr/>
+        <p:txBody>
+          <a:bodyPr/>
+          <a:lstStyle/>
+          <a:p/>
+        </p:txBody>
+      </p:sp>
+      <p:sp>
+        <p:nvSpPr>
+          <p:cNvPr id="3" name="TextBox 2"/>
+          <p:cNvSpPr txBox="1"/>
+          <p:nvPr/>
+        </p:nvSpPr>
+        <p:spPr>
+          <a:xfrm>
+            <a:off x="457200" y="182880"/>
+            <a:ext cx="10972800" cy="548640"/>
+          </a:xfrm>
+          <a:prstGeom prst="rect">
+            <a:avLst/>
+          </a:prstGeom>
+          <a:noFill/>
+        </p:spPr>
+        <p:txBody>
+          <a:bodyPr wrap="square">
+            <a:spAutoFit/>
+          </a:bodyPr>
+          <a:lstStyle/>
+          <a:p>
+            <a:r>
+              <a:rPr sz="2400" b="1"/>
+              <a:t>Figure 2</a:t>
+            </a:r>
+          </a:p>
+        </p:txBody>
+      </p:sp>
+      <p:pic>
+        <p:nvPicPr>
+          <p:cNvPr id="4" name="Picture 3" descr="pachelbel_score_schema.png"/>
+          <p:cNvPicPr>
+            <a:picLocks noChangeAspect="1"/>
+          </p:cNvPicPr>
+          <p:nvPr/>
+        </p:nvPicPr>
+        <p:blipFill>
+          <a:blip r:embed="rId2"/>
+          <a:stretch>
+            <a:fillRect/>
+          </a:stretch>
+        </p:blipFill>
+        <p:spPr>
+          <a:xfrm>
+            <a:off x="914400" y="914400"/>
+            <a:ext cx="10058400" cy="4114800"/>
+          </a:xfrm>
+          <a:prstGeom prst="rect">
+            <a:avLst/>
+          </a:prstGeom>
+        </p:spPr>
+      </p:pic>
+      <p:sp>
+        <p:nvSpPr>
+          <p:cNvPr id="5" name="TextBox 4"/>
+          <p:cNvSpPr txBox="1"/>
+          <p:nvPr/>
+        </p:nvSpPr>
+        <p:spPr>
+          <a:xfrm>
+            <a:off x="457200" y="5303520"/>
+            <a:ext cx="10972800" cy="1371600"/>
+          </a:xfrm>
+          <a:prstGeom prst="rect">
+            <a:avLst/>
+          </a:prstGeom>
+          <a:noFill/>
+        </p:spPr>
+        <p:txBody>
+          <a:bodyPr wrap="square">
+            <a:spAutoFit/>
+          </a:bodyPr>
+          <a:lstStyle/>
+          <a:p>
+            <a:r>
+              <a:rPr sz="1400" i="1"/>
+              <a:t>Figure 2. Harmonic tension profile of Pachelbel's Canon encoded as SITS9 instructions. Bar colour = instruction type (blue = ANCHOR, red = FWD, green = RET). Bar height = TENSION. Dashed line traces the tension arc.</a:t>
+            </a:r>
+          </a:p>
+        </p:txBody>
+      </p:sp>
+    </p:spTree>
+  </p:cSld>
+  <p:clrMapOvr>
+    <a:masterClrMapping/>
+  </p:clrMapOvr>
+</p:sld>
+</file>
+
+<file path=ppt/slides/slide3.xml><?xml version="1.0" encoding="utf-8"?>
+<p:sld xmlns:a="http://schemas.openxmlformats.org/drawingml/2006/main" xmlns:p="http://schemas.openxmlformats.org/presentationml/2006/main" xmlns:r="http://schemas.openxmlformats.org/officeDocument/2006/relationships">
+  <p:cSld>
+    <p:spTree>
+      <p:nvGrpSpPr>
+        <p:cNvPr id="1" name=""/>
+        <p:cNvGrpSpPr/>
+        <p:nvPr/>
+      </p:nvGrpSpPr>
+      <p:grpSpPr/>
+      <p:sp>
+        <p:nvSpPr>
+          <p:cNvPr id="2" name="Title 1"/>
+          <p:cNvSpPr>
+            <a:spLocks noGrp="1"/>
+          </p:cNvSpPr>
+          <p:nvPr>
+            <p:ph type="title"/>
+          </p:nvPr>
+        </p:nvSpPr>
+        <p:spPr/>
+        <p:txBody>
+          <a:bodyPr/>
+          <a:lstStyle/>
+          <a:p/>
+        </p:txBody>
+      </p:sp>
+      <p:sp>
+        <p:nvSpPr>
+          <p:cNvPr id="3" name="TextBox 2"/>
+          <p:cNvSpPr txBox="1"/>
+          <p:nvPr/>
+        </p:nvSpPr>
+        <p:spPr>
+          <a:xfrm>
+            <a:off x="457200" y="182880"/>
+            <a:ext cx="10972800" cy="548640"/>
+          </a:xfrm>
+          <a:prstGeom prst="rect">
+            <a:avLst/>
+          </a:prstGeom>
+          <a:noFill/>
+        </p:spPr>
+        <p:txBody>
+          <a:bodyPr wrap="square">
+            <a:spAutoFit/>
+          </a:bodyPr>
+          <a:lstStyle/>
+          <a:p>
+            <a:r>
+              <a:rPr sz="2400" b="1"/>
+              <a:t>Figure 3</a:t>
+            </a:r>
+          </a:p>
+        </p:txBody>
+      </p:sp>
+      <p:pic>
+        <p:nvPicPr>
+          <p:cNvPr id="4" name="Picture 3" descr="pachelbel_textile_schema.png"/>
+          <p:cNvPicPr>
+            <a:picLocks noChangeAspect="1"/>
+          </p:cNvPicPr>
+          <p:nvPr/>
+        </p:nvPicPr>
+        <p:blipFill>
+          <a:blip r:embed="rId2"/>
+          <a:stretch>
+            <a:fillRect/>
+          </a:stretch>
+        </p:blipFill>
+        <p:spPr>
+          <a:xfrm>
+            <a:off x="914400" y="914400"/>
+            <a:ext cx="10058400" cy="4114800"/>
+          </a:xfrm>
+          <a:prstGeom prst="rect">
+            <a:avLst/>
+          </a:prstGeom>
+        </p:spPr>
+      </p:pic>
+      <p:sp>
+        <p:nvSpPr>
+          <p:cNvPr id="5" name="TextBox 4"/>
+          <p:cNvSpPr txBox="1"/>
+          <p:nvPr/>
+        </p:nvSpPr>
+        <p:spPr>
+          <a:xfrm>
+            <a:off x="457200" y="5303520"/>
+            <a:ext cx="10972800" cy="1371600"/>
+          </a:xfrm>
+          <a:prstGeom prst="rect">
+            <a:avLst/>
+          </a:prstGeom>
+          <a:noFill/>
+        </p:spPr>
+        <p:txBody>
+          <a:bodyPr wrap="square">
+            <a:spAutoFit/>
+          </a:bodyPr>
+          <a:lstStyle/>
+          <a:p>
+            <a:r>
+              <a:rPr sz="1400" i="1"/>
+              <a:t>Figure 3. Textile schema (back-stitch pattern) for Pachelbel's Canon. Needle path alternates between surface (orange) and back (blue). Red = FWD on surface; orange diagonals = CROSS; black dot = ANCHOR (knot).</a:t>
+            </a:r>
+          </a:p>
+        </p:txBody>
+      </p:sp>
+    </p:spTree>
+  </p:cSld>
+  <p:clrMapOvr>
+    <a:masterClrMapping/>
+  </p:clrMapOvr>
+</p:sld>
+</file>
+
+<file path=ppt/slides/slide4.xml><?xml version="1.0" encoding="utf-8"?>
+<p:sld xmlns:a="http://schemas.openxmlformats.org/drawingml/2006/main" xmlns:p="http://schemas.openxmlformats.org/presentationml/2006/main" xmlns:r="http://schemas.openxmlformats.org/officeDocument/2006/relationships">
+  <p:cSld>
+    <p:spTree>
+      <p:nvGrpSpPr>
+        <p:cNvPr id="1" name=""/>
+        <p:cNvGrpSpPr/>
+        <p:nvPr/>
+      </p:nvGrpSpPr>
+      <p:grpSpPr/>
+      <p:sp>
+        <p:nvSpPr>
+          <p:cNvPr id="2" name="Title 1"/>
+          <p:cNvSpPr>
+            <a:spLocks noGrp="1"/>
+          </p:cNvSpPr>
+          <p:nvPr>
+            <p:ph type="title"/>
+          </p:nvPr>
+        </p:nvSpPr>
+        <p:spPr/>
+        <p:txBody>
+          <a:bodyPr/>
+          <a:lstStyle/>
+          <a:p/>
+        </p:txBody>
+      </p:sp>
+      <p:sp>
+        <p:nvSpPr>
+          <p:cNvPr id="3" name="TextBox 2"/>
+          <p:cNvSpPr txBox="1"/>
+          <p:nvPr/>
+        </p:nvSpPr>
+        <p:spPr>
+          <a:xfrm>
+            <a:off x="457200" y="182880"/>
+            <a:ext cx="10972800" cy="548640"/>
+          </a:xfrm>
+          <a:prstGeom prst="rect">
+            <a:avLst/>
+          </a:prstGeom>
+          <a:noFill/>
+        </p:spPr>
+        <p:txBody>
+          <a:bodyPr wrap="square">
+            <a:spAutoFit/>
+          </a:bodyPr>
+          <a:lstStyle/>
+          <a:p>
+            <a:r>
+              <a:rPr sz="2400" b="1"/>
+              <a:t>Figure 4</a:t>
+            </a:r>
+          </a:p>
+        </p:txBody>
+      </p:sp>
+      <p:pic>
+        <p:nvPicPr>
+          <p:cNvPr id="4" name="Picture 3" descr="pachelbel_cooking_schema.png"/>
+          <p:cNvPicPr>
+            <a:picLocks noChangeAspect="1"/>
+          </p:cNvPicPr>
+          <p:nvPr/>
+        </p:nvPicPr>
+        <p:blipFill>
+          <a:blip r:embed="rId2"/>
+          <a:stretch>
+            <a:fillRect/>
+          </a:stretch>
+        </p:blipFill>
+        <p:spPr>
+          <a:xfrm>
+            <a:off x="914400" y="914400"/>
+            <a:ext cx="10058400" cy="4114800"/>
+          </a:xfrm>
+          <a:prstGeom prst="rect">
+            <a:avLst/>
+          </a:prstGeom>
+        </p:spPr>
+      </p:pic>
+      <p:sp>
+        <p:nvSpPr>
+          <p:cNvPr id="5" name="TextBox 4"/>
+          <p:cNvSpPr txBox="1"/>
+          <p:nvPr/>
+        </p:nvSpPr>
+        <p:spPr>
+          <a:xfrm>
+            <a:off x="457200" y="5303520"/>
+            <a:ext cx="10972800" cy="1371600"/>
+          </a:xfrm>
+          <a:prstGeom prst="rect">
+            <a:avLst/>
+          </a:prstGeom>
+          <a:noFill/>
+        </p:spPr>
+        <p:txBody>
+          <a:bodyPr wrap="square">
+            <a:spAutoFit/>
+          </a:bodyPr>
+          <a:lstStyle/>
+          <a:p>
+            <a:r>
+              <a:rPr sz="1400" i="1"/>
+              <a:t>Figure 4. Cooking schema for Pachelbel's Canon. Heat curve (TENSION) follows the harmonic tension profile. Background zones: red = grill, blue = simmer, green = steam. Dashed vertical = CROSS (method switch).</a:t>
             </a:r>
           </a:p>
         </p:txBody>

</xml_diff>